<commit_message>
Update project results and deliverables
</commit_message>
<xml_diff>
--- a/docs/presentation.pptx
+++ b/docs/presentation.pptx
@@ -4836,7 +4836,7 @@
       </p:sp>
       <p:pic>
         <p:nvPicPr>
-          <p:cNvPr id="4" name="Picture 3" descr="demo_map.png"/>
+          <p:cNvPr id="4" name="Picture 3" descr="map.png"/>
           <p:cNvPicPr>
             <a:picLocks noChangeAspect="1"/>
           </p:cNvPicPr>
@@ -4851,7 +4851,7 @@
         <p:spPr>
           <a:xfrm>
             <a:off x="5486400" y="1645920"/>
-            <a:ext cx="6035040" cy="8386230"/>
+            <a:ext cx="6035040" cy="1737038"/>
           </a:xfrm>
           <a:prstGeom prst="rect">
             <a:avLst/>

</xml_diff>